<commit_message>
Cleaning up and README addition
</commit_message>
<xml_diff>
--- a/lessons_learned_on_LLM_inference.pptx
+++ b/lessons_learned_on_LLM_inference.pptx
@@ -5,23 +5,26 @@
     <p:sldMasterId id="2147483648" r:id="rId1"/>
   </p:sldMasterIdLst>
   <p:notesMasterIdLst>
-    <p:notesMasterId r:id="rId16"/>
+    <p:notesMasterId r:id="rId19"/>
   </p:notesMasterIdLst>
   <p:sldIdLst>
     <p:sldId id="290" r:id="rId2"/>
     <p:sldId id="298" r:id="rId3"/>
     <p:sldId id="296" r:id="rId4"/>
-    <p:sldId id="293" r:id="rId5"/>
-    <p:sldId id="294" r:id="rId6"/>
-    <p:sldId id="291" r:id="rId7"/>
-    <p:sldId id="297" r:id="rId8"/>
-    <p:sldId id="295" r:id="rId9"/>
-    <p:sldId id="292" r:id="rId10"/>
-    <p:sldId id="300" r:id="rId11"/>
-    <p:sldId id="299" r:id="rId12"/>
-    <p:sldId id="301" r:id="rId13"/>
-    <p:sldId id="303" r:id="rId14"/>
-    <p:sldId id="302" r:id="rId15"/>
+    <p:sldId id="304" r:id="rId5"/>
+    <p:sldId id="293" r:id="rId6"/>
+    <p:sldId id="294" r:id="rId7"/>
+    <p:sldId id="291" r:id="rId8"/>
+    <p:sldId id="297" r:id="rId9"/>
+    <p:sldId id="295" r:id="rId10"/>
+    <p:sldId id="306" r:id="rId11"/>
+    <p:sldId id="305" r:id="rId12"/>
+    <p:sldId id="292" r:id="rId13"/>
+    <p:sldId id="300" r:id="rId14"/>
+    <p:sldId id="299" r:id="rId15"/>
+    <p:sldId id="301" r:id="rId16"/>
+    <p:sldId id="303" r:id="rId17"/>
+    <p:sldId id="302" r:id="rId18"/>
   </p:sldIdLst>
   <p:sldSz cx="12192000" cy="6858000"/>
   <p:notesSz cx="6858000" cy="9144000"/>
@@ -210,7 +213,7 @@
           <a:p>
             <a:fld id="{30947E8E-88EA-46C6-BB15-A5D28211A557}" type="datetimeFigureOut">
               <a:rPr lang="it-IT" smtClean="0"/>
-              <a:t>13/05/2026</a:t>
+              <a:t>18/05/2026</a:t>
             </a:fld>
             <a:endParaRPr lang="it-IT"/>
           </a:p>
@@ -20790,10 +20793,10 @@
       </p:grpSpPr>
       <p:sp>
         <p:nvSpPr>
-          <p:cNvPr id="5" name="Title 4">
-            <a:extLst>
-              <a:ext uri="{FF2B5EF4-FFF2-40B4-BE49-F238E27FC236}">
-                <a16:creationId xmlns:a16="http://schemas.microsoft.com/office/drawing/2014/main" id="{175B83D3-5577-0B89-8C4F-CE24306BFBEC}"/>
+          <p:cNvPr id="2" name="Title 1">
+            <a:extLst>
+              <a:ext uri="{FF2B5EF4-FFF2-40B4-BE49-F238E27FC236}">
+                <a16:creationId xmlns:a16="http://schemas.microsoft.com/office/drawing/2014/main" id="{D23DF994-FB58-BFCC-8B40-3B4A635B4378}"/>
               </a:ext>
             </a:extLst>
           </p:cNvPr>
@@ -20811,7 +20814,7 @@
           <a:p>
             <a:r>
               <a:rPr lang="it-IT" dirty="0"/>
-              <a:t>Some Preliminary Results</a:t>
+              <a:t>Cost of Preemption?</a:t>
             </a:r>
             <a:endParaRPr lang="en-US" dirty="0"/>
           </a:p>
@@ -20819,10 +20822,10 @@
       </p:sp>
       <p:sp>
         <p:nvSpPr>
-          <p:cNvPr id="6" name="Text Placeholder 5">
-            <a:extLst>
-              <a:ext uri="{FF2B5EF4-FFF2-40B4-BE49-F238E27FC236}">
-                <a16:creationId xmlns:a16="http://schemas.microsoft.com/office/drawing/2014/main" id="{211E3B8A-E30A-70C9-109A-891BDC6F5571}"/>
+          <p:cNvPr id="3" name="Content Placeholder 2">
+            <a:extLst>
+              <a:ext uri="{FF2B5EF4-FFF2-40B4-BE49-F238E27FC236}">
+                <a16:creationId xmlns:a16="http://schemas.microsoft.com/office/drawing/2014/main" id="{8333C5B2-C01F-5327-45F2-9378554ACF5B}"/>
               </a:ext>
             </a:extLst>
           </p:cNvPr>
@@ -20830,7 +20833,7 @@
             <a:spLocks noGrp="1"/>
           </p:cNvSpPr>
           <p:nvPr>
-            <p:ph type="body" idx="1"/>
+            <p:ph idx="1"/>
           </p:nvPr>
         </p:nvSpPr>
         <p:spPr/>
@@ -20840,9 +20843,34 @@
           <a:p>
             <a:r>
               <a:rPr lang="it-IT" dirty="0"/>
-              <a:t>Preliminary Performance Results using Vidur</a:t>
-            </a:r>
-            <a:endParaRPr lang="en-US" dirty="0"/>
+              <a:t>«Freeing» memory costs </a:t>
+            </a:r>
+            <a:r>
+              <a:rPr lang="en-US" dirty="0"/>
+              <a:t>~ 0</a:t>
+            </a:r>
+            <a:endParaRPr lang="it-IT" dirty="0"/>
+          </a:p>
+          <a:p>
+            <a:pPr lvl="1"/>
+            <a:r>
+              <a:rPr lang="it-IT" dirty="0"/>
+              <a:t>You do not delete the actual (GPU) memory</a:t>
+            </a:r>
+          </a:p>
+          <a:p>
+            <a:pPr lvl="1"/>
+            <a:r>
+              <a:rPr lang="en-US" dirty="0"/>
+              <a:t>You work on memory-occupancy metadata</a:t>
+            </a:r>
+          </a:p>
+          <a:p>
+            <a:pPr lvl="1"/>
+            <a:r>
+              <a:rPr lang="en-US" dirty="0"/>
+              <a:t>… </a:t>
+            </a:r>
           </a:p>
         </p:txBody>
       </p:sp>
@@ -20851,7 +20879,7 @@
           <p:cNvPr id="4" name="Slide Number Placeholder 3">
             <a:extLst>
               <a:ext uri="{FF2B5EF4-FFF2-40B4-BE49-F238E27FC236}">
-                <a16:creationId xmlns:a16="http://schemas.microsoft.com/office/drawing/2014/main" id="{B973941E-E5F9-BA54-71DA-522F9CBAABDC}"/>
+                <a16:creationId xmlns:a16="http://schemas.microsoft.com/office/drawing/2014/main" id="{FE8B1AF3-0E8A-4209-60FB-463882A55372}"/>
               </a:ext>
             </a:extLst>
           </p:cNvPr>
@@ -20859,15 +20887,10 @@
             <a:spLocks noGrp="1"/>
           </p:cNvSpPr>
           <p:nvPr>
-            <p:ph type="sldNum" sz="quarter" idx="4294967295"/>
+            <p:ph type="sldNum" sz="quarter" idx="12"/>
           </p:nvPr>
         </p:nvSpPr>
-        <p:spPr>
-          <a:xfrm>
-            <a:off x="11579225" y="6372225"/>
-            <a:ext cx="612775" cy="371475"/>
-          </a:xfrm>
-        </p:spPr>
+        <p:spPr/>
         <p:txBody>
           <a:bodyPr/>
           <a:lstStyle/>
@@ -20883,7 +20906,7 @@
     </p:spTree>
     <p:extLst>
       <p:ext uri="{BB962C8B-B14F-4D97-AF65-F5344CB8AC3E}">
-        <p14:creationId xmlns:p14="http://schemas.microsoft.com/office/powerpoint/2010/main" val="2074295844"/>
+        <p14:creationId xmlns:p14="http://schemas.microsoft.com/office/powerpoint/2010/main" val="956285018"/>
       </p:ext>
     </p:extLst>
   </p:cSld>
@@ -20912,10 +20935,10 @@
       </p:grpSpPr>
       <p:sp>
         <p:nvSpPr>
-          <p:cNvPr id="2" name="Title 1">
-            <a:extLst>
-              <a:ext uri="{FF2B5EF4-FFF2-40B4-BE49-F238E27FC236}">
-                <a16:creationId xmlns:a16="http://schemas.microsoft.com/office/drawing/2014/main" id="{8142037E-7213-7E7C-FC78-2064B6448E04}"/>
+          <p:cNvPr id="5" name="Title 4">
+            <a:extLst>
+              <a:ext uri="{FF2B5EF4-FFF2-40B4-BE49-F238E27FC236}">
+                <a16:creationId xmlns:a16="http://schemas.microsoft.com/office/drawing/2014/main" id="{D1DA01BA-0294-ACF5-D7AC-FBCAD76E17AC}"/>
               </a:ext>
             </a:extLst>
           </p:cNvPr>
@@ -20933,7 +20956,7 @@
           <a:p>
             <a:r>
               <a:rPr lang="it-IT" dirty="0"/>
-              <a:t>Performance Metrics</a:t>
+              <a:t>Optimizations</a:t>
             </a:r>
             <a:endParaRPr lang="en-US" dirty="0"/>
           </a:p>
@@ -20941,10 +20964,132 @@
       </p:sp>
       <p:sp>
         <p:nvSpPr>
+          <p:cNvPr id="6" name="Text Placeholder 5">
+            <a:extLst>
+              <a:ext uri="{FF2B5EF4-FFF2-40B4-BE49-F238E27FC236}">
+                <a16:creationId xmlns:a16="http://schemas.microsoft.com/office/drawing/2014/main" id="{F8FC2B65-2AAB-8554-EFF9-CB29DF2B65CF}"/>
+              </a:ext>
+            </a:extLst>
+          </p:cNvPr>
+          <p:cNvSpPr>
+            <a:spLocks noGrp="1"/>
+          </p:cNvSpPr>
+          <p:nvPr>
+            <p:ph type="body" idx="1"/>
+          </p:nvPr>
+        </p:nvSpPr>
+        <p:spPr/>
+        <p:txBody>
+          <a:bodyPr/>
+          <a:lstStyle/>
+          <a:p>
+            <a:r>
+              <a:rPr lang="it-IT" dirty="0"/>
+              <a:t>How to use tweeks to improve performances?</a:t>
+            </a:r>
+            <a:endParaRPr lang="en-US" dirty="0"/>
+          </a:p>
+        </p:txBody>
+      </p:sp>
+      <p:sp>
+        <p:nvSpPr>
+          <p:cNvPr id="4" name="Slide Number Placeholder 3">
+            <a:extLst>
+              <a:ext uri="{FF2B5EF4-FFF2-40B4-BE49-F238E27FC236}">
+                <a16:creationId xmlns:a16="http://schemas.microsoft.com/office/drawing/2014/main" id="{5F32729F-5AA2-DA42-4326-5DE3FA7847C4}"/>
+              </a:ext>
+            </a:extLst>
+          </p:cNvPr>
+          <p:cNvSpPr>
+            <a:spLocks noGrp="1"/>
+          </p:cNvSpPr>
+          <p:nvPr>
+            <p:ph type="sldNum" sz="quarter" idx="4294967295"/>
+          </p:nvPr>
+        </p:nvSpPr>
+        <p:spPr>
+          <a:xfrm>
+            <a:off x="11579225" y="6372225"/>
+            <a:ext cx="612775" cy="371475"/>
+          </a:xfrm>
+        </p:spPr>
+        <p:txBody>
+          <a:bodyPr/>
+          <a:lstStyle/>
+          <a:p>
+            <a:fld id="{77E0F69E-94E4-477D-9D2E-ABE325801752}" type="slidenum">
+              <a:rPr lang="it-IT" smtClean="0"/>
+              <a:t>11</a:t>
+            </a:fld>
+            <a:endParaRPr lang="it-IT"/>
+          </a:p>
+        </p:txBody>
+      </p:sp>
+    </p:spTree>
+    <p:extLst>
+      <p:ext uri="{BB962C8B-B14F-4D97-AF65-F5344CB8AC3E}">
+        <p14:creationId xmlns:p14="http://schemas.microsoft.com/office/powerpoint/2010/main" val="3313396396"/>
+      </p:ext>
+    </p:extLst>
+  </p:cSld>
+  <p:clrMapOvr>
+    <a:masterClrMapping/>
+  </p:clrMapOvr>
+</p:sld>
+</file>
+
+<file path=ppt/slides/slide12.xml><?xml version="1.0" encoding="utf-8"?>
+<p:sld xmlns:a="http://schemas.openxmlformats.org/drawingml/2006/main" xmlns:r="http://schemas.openxmlformats.org/officeDocument/2006/relationships" xmlns:p="http://schemas.openxmlformats.org/presentationml/2006/main">
+  <p:cSld>
+    <p:spTree>
+      <p:nvGrpSpPr>
+        <p:cNvPr id="1" name=""/>
+        <p:cNvGrpSpPr/>
+        <p:nvPr/>
+      </p:nvGrpSpPr>
+      <p:grpSpPr>
+        <a:xfrm>
+          <a:off x="0" y="0"/>
+          <a:ext cx="0" cy="0"/>
+          <a:chOff x="0" y="0"/>
+          <a:chExt cx="0" cy="0"/>
+        </a:xfrm>
+      </p:grpSpPr>
+      <p:sp>
+        <p:nvSpPr>
+          <p:cNvPr id="2" name="Title 1">
+            <a:extLst>
+              <a:ext uri="{FF2B5EF4-FFF2-40B4-BE49-F238E27FC236}">
+                <a16:creationId xmlns:a16="http://schemas.microsoft.com/office/drawing/2014/main" id="{8EEBE812-C639-0DE1-6B7A-FC54478B5362}"/>
+              </a:ext>
+            </a:extLst>
+          </p:cNvPr>
+          <p:cNvSpPr>
+            <a:spLocks noGrp="1"/>
+          </p:cNvSpPr>
+          <p:nvPr>
+            <p:ph type="title"/>
+          </p:nvPr>
+        </p:nvSpPr>
+        <p:spPr/>
+        <p:txBody>
+          <a:bodyPr/>
+          <a:lstStyle/>
+          <a:p>
+            <a:r>
+              <a:rPr lang="it-IT" dirty="0"/>
+              <a:t>Speculative Decoding</a:t>
+            </a:r>
+            <a:endParaRPr lang="en-US" dirty="0"/>
+          </a:p>
+        </p:txBody>
+      </p:sp>
+      <p:sp>
+        <p:nvSpPr>
           <p:cNvPr id="3" name="Content Placeholder 2">
             <a:extLst>
               <a:ext uri="{FF2B5EF4-FFF2-40B4-BE49-F238E27FC236}">
-                <a16:creationId xmlns:a16="http://schemas.microsoft.com/office/drawing/2014/main" id="{D80C7F41-31A7-91CA-4CDD-CE0F5210063D}"/>
+                <a16:creationId xmlns:a16="http://schemas.microsoft.com/office/drawing/2014/main" id="{4DA9F494-C72A-7E1D-05A8-E6D6BD423D75}"/>
               </a:ext>
             </a:extLst>
           </p:cNvPr>
@@ -20960,57 +21105,7 @@
           <a:bodyPr/>
           <a:lstStyle/>
           <a:p>
-            <a:r>
-              <a:rPr lang="it-IT" b="1" dirty="0"/>
-              <a:t>E2ED</a:t>
-            </a:r>
-            <a:r>
-              <a:rPr lang="it-IT" dirty="0"/>
-              <a:t>: end-to-end delay</a:t>
-            </a:r>
-          </a:p>
-          <a:p>
-            <a:r>
-              <a:rPr lang="it-IT" b="1" dirty="0"/>
-              <a:t>TTFT</a:t>
-            </a:r>
-            <a:r>
-              <a:rPr lang="it-IT" dirty="0"/>
-              <a:t>: time-to-first token</a:t>
-            </a:r>
-          </a:p>
-          <a:p>
-            <a:r>
-              <a:rPr lang="it-IT" b="1" dirty="0"/>
-              <a:t>TPOT</a:t>
-            </a:r>
-            <a:r>
-              <a:rPr lang="it-IT" dirty="0"/>
-              <a:t>: time-per-output-token</a:t>
-            </a:r>
-          </a:p>
-          <a:p>
-            <a:pPr lvl="1"/>
-            <a:r>
-              <a:rPr lang="it-IT" dirty="0"/>
-              <a:t>Average time spent to generate each output token (decode time / number of generated tokens)</a:t>
-            </a:r>
-          </a:p>
-          <a:p>
-            <a:pPr lvl="1"/>
-            <a:r>
-              <a:rPr lang="it-IT" dirty="0"/>
-              <a:t>Decode-phase metric</a:t>
-            </a:r>
-          </a:p>
-          <a:p>
-            <a:r>
-              <a:rPr lang="it-IT" dirty="0"/>
-              <a:t># of preemptions (the job already done is lost)</a:t>
-            </a:r>
-          </a:p>
-          <a:p>
-            <a:endParaRPr lang="en-US" dirty="0"/>
+            <a:endParaRPr lang="en-US"/>
           </a:p>
         </p:txBody>
       </p:sp>
@@ -21019,7 +21114,7 @@
           <p:cNvPr id="4" name="Slide Number Placeholder 3">
             <a:extLst>
               <a:ext uri="{FF2B5EF4-FFF2-40B4-BE49-F238E27FC236}">
-                <a16:creationId xmlns:a16="http://schemas.microsoft.com/office/drawing/2014/main" id="{A181C1D1-159B-28FB-57D4-BA87A8B1C8CD}"/>
+                <a16:creationId xmlns:a16="http://schemas.microsoft.com/office/drawing/2014/main" id="{88569CC1-DBA1-2C82-22D1-2097554AFA3A}"/>
               </a:ext>
             </a:extLst>
           </p:cNvPr>
@@ -21037,7 +21132,292 @@
           <a:p>
             <a:fld id="{77E0F69E-94E4-477D-9D2E-ABE325801752}" type="slidenum">
               <a:rPr lang="it-IT" smtClean="0"/>
-              <a:t>11</a:t>
+              <a:t>12</a:t>
+            </a:fld>
+            <a:endParaRPr lang="it-IT"/>
+          </a:p>
+        </p:txBody>
+      </p:sp>
+    </p:spTree>
+    <p:extLst>
+      <p:ext uri="{BB962C8B-B14F-4D97-AF65-F5344CB8AC3E}">
+        <p14:creationId xmlns:p14="http://schemas.microsoft.com/office/powerpoint/2010/main" val="1602372300"/>
+      </p:ext>
+    </p:extLst>
+  </p:cSld>
+  <p:clrMapOvr>
+    <a:masterClrMapping/>
+  </p:clrMapOvr>
+</p:sld>
+</file>
+
+<file path=ppt/slides/slide13.xml><?xml version="1.0" encoding="utf-8"?>
+<p:sld xmlns:a="http://schemas.openxmlformats.org/drawingml/2006/main" xmlns:r="http://schemas.openxmlformats.org/officeDocument/2006/relationships" xmlns:p="http://schemas.openxmlformats.org/presentationml/2006/main">
+  <p:cSld>
+    <p:spTree>
+      <p:nvGrpSpPr>
+        <p:cNvPr id="1" name=""/>
+        <p:cNvGrpSpPr/>
+        <p:nvPr/>
+      </p:nvGrpSpPr>
+      <p:grpSpPr>
+        <a:xfrm>
+          <a:off x="0" y="0"/>
+          <a:ext cx="0" cy="0"/>
+          <a:chOff x="0" y="0"/>
+          <a:chExt cx="0" cy="0"/>
+        </a:xfrm>
+      </p:grpSpPr>
+      <p:sp>
+        <p:nvSpPr>
+          <p:cNvPr id="5" name="Title 4">
+            <a:extLst>
+              <a:ext uri="{FF2B5EF4-FFF2-40B4-BE49-F238E27FC236}">
+                <a16:creationId xmlns:a16="http://schemas.microsoft.com/office/drawing/2014/main" id="{175B83D3-5577-0B89-8C4F-CE24306BFBEC}"/>
+              </a:ext>
+            </a:extLst>
+          </p:cNvPr>
+          <p:cNvSpPr>
+            <a:spLocks noGrp="1"/>
+          </p:cNvSpPr>
+          <p:nvPr>
+            <p:ph type="title"/>
+          </p:nvPr>
+        </p:nvSpPr>
+        <p:spPr/>
+        <p:txBody>
+          <a:bodyPr/>
+          <a:lstStyle/>
+          <a:p>
+            <a:r>
+              <a:rPr lang="it-IT" dirty="0"/>
+              <a:t>Some Preliminary Results</a:t>
+            </a:r>
+            <a:endParaRPr lang="en-US" dirty="0"/>
+          </a:p>
+        </p:txBody>
+      </p:sp>
+      <p:sp>
+        <p:nvSpPr>
+          <p:cNvPr id="6" name="Text Placeholder 5">
+            <a:extLst>
+              <a:ext uri="{FF2B5EF4-FFF2-40B4-BE49-F238E27FC236}">
+                <a16:creationId xmlns:a16="http://schemas.microsoft.com/office/drawing/2014/main" id="{211E3B8A-E30A-70C9-109A-891BDC6F5571}"/>
+              </a:ext>
+            </a:extLst>
+          </p:cNvPr>
+          <p:cNvSpPr>
+            <a:spLocks noGrp="1"/>
+          </p:cNvSpPr>
+          <p:nvPr>
+            <p:ph type="body" idx="1"/>
+          </p:nvPr>
+        </p:nvSpPr>
+        <p:spPr/>
+        <p:txBody>
+          <a:bodyPr/>
+          <a:lstStyle/>
+          <a:p>
+            <a:r>
+              <a:rPr lang="it-IT" dirty="0"/>
+              <a:t>Preliminary Performance Results using Vidur</a:t>
+            </a:r>
+            <a:endParaRPr lang="en-US" dirty="0"/>
+          </a:p>
+        </p:txBody>
+      </p:sp>
+      <p:sp>
+        <p:nvSpPr>
+          <p:cNvPr id="4" name="Slide Number Placeholder 3">
+            <a:extLst>
+              <a:ext uri="{FF2B5EF4-FFF2-40B4-BE49-F238E27FC236}">
+                <a16:creationId xmlns:a16="http://schemas.microsoft.com/office/drawing/2014/main" id="{B973941E-E5F9-BA54-71DA-522F9CBAABDC}"/>
+              </a:ext>
+            </a:extLst>
+          </p:cNvPr>
+          <p:cNvSpPr>
+            <a:spLocks noGrp="1"/>
+          </p:cNvSpPr>
+          <p:nvPr>
+            <p:ph type="sldNum" sz="quarter" idx="4294967295"/>
+          </p:nvPr>
+        </p:nvSpPr>
+        <p:spPr>
+          <a:xfrm>
+            <a:off x="11579225" y="6372225"/>
+            <a:ext cx="612775" cy="371475"/>
+          </a:xfrm>
+        </p:spPr>
+        <p:txBody>
+          <a:bodyPr/>
+          <a:lstStyle/>
+          <a:p>
+            <a:fld id="{77E0F69E-94E4-477D-9D2E-ABE325801752}" type="slidenum">
+              <a:rPr lang="it-IT" smtClean="0"/>
+              <a:t>13</a:t>
+            </a:fld>
+            <a:endParaRPr lang="it-IT"/>
+          </a:p>
+        </p:txBody>
+      </p:sp>
+    </p:spTree>
+    <p:extLst>
+      <p:ext uri="{BB962C8B-B14F-4D97-AF65-F5344CB8AC3E}">
+        <p14:creationId xmlns:p14="http://schemas.microsoft.com/office/powerpoint/2010/main" val="2074295844"/>
+      </p:ext>
+    </p:extLst>
+  </p:cSld>
+  <p:clrMapOvr>
+    <a:masterClrMapping/>
+  </p:clrMapOvr>
+</p:sld>
+</file>
+
+<file path=ppt/slides/slide14.xml><?xml version="1.0" encoding="utf-8"?>
+<p:sld xmlns:a="http://schemas.openxmlformats.org/drawingml/2006/main" xmlns:r="http://schemas.openxmlformats.org/officeDocument/2006/relationships" xmlns:p="http://schemas.openxmlformats.org/presentationml/2006/main">
+  <p:cSld>
+    <p:spTree>
+      <p:nvGrpSpPr>
+        <p:cNvPr id="1" name=""/>
+        <p:cNvGrpSpPr/>
+        <p:nvPr/>
+      </p:nvGrpSpPr>
+      <p:grpSpPr>
+        <a:xfrm>
+          <a:off x="0" y="0"/>
+          <a:ext cx="0" cy="0"/>
+          <a:chOff x="0" y="0"/>
+          <a:chExt cx="0" cy="0"/>
+        </a:xfrm>
+      </p:grpSpPr>
+      <p:sp>
+        <p:nvSpPr>
+          <p:cNvPr id="2" name="Title 1">
+            <a:extLst>
+              <a:ext uri="{FF2B5EF4-FFF2-40B4-BE49-F238E27FC236}">
+                <a16:creationId xmlns:a16="http://schemas.microsoft.com/office/drawing/2014/main" id="{8142037E-7213-7E7C-FC78-2064B6448E04}"/>
+              </a:ext>
+            </a:extLst>
+          </p:cNvPr>
+          <p:cNvSpPr>
+            <a:spLocks noGrp="1"/>
+          </p:cNvSpPr>
+          <p:nvPr>
+            <p:ph type="title"/>
+          </p:nvPr>
+        </p:nvSpPr>
+        <p:spPr/>
+        <p:txBody>
+          <a:bodyPr/>
+          <a:lstStyle/>
+          <a:p>
+            <a:r>
+              <a:rPr lang="it-IT" dirty="0"/>
+              <a:t>Performance Metrics</a:t>
+            </a:r>
+            <a:endParaRPr lang="en-US" dirty="0"/>
+          </a:p>
+        </p:txBody>
+      </p:sp>
+      <p:sp>
+        <p:nvSpPr>
+          <p:cNvPr id="3" name="Content Placeholder 2">
+            <a:extLst>
+              <a:ext uri="{FF2B5EF4-FFF2-40B4-BE49-F238E27FC236}">
+                <a16:creationId xmlns:a16="http://schemas.microsoft.com/office/drawing/2014/main" id="{D80C7F41-31A7-91CA-4CDD-CE0F5210063D}"/>
+              </a:ext>
+            </a:extLst>
+          </p:cNvPr>
+          <p:cNvSpPr>
+            <a:spLocks noGrp="1"/>
+          </p:cNvSpPr>
+          <p:nvPr>
+            <p:ph idx="1"/>
+          </p:nvPr>
+        </p:nvSpPr>
+        <p:spPr/>
+        <p:txBody>
+          <a:bodyPr/>
+          <a:lstStyle/>
+          <a:p>
+            <a:r>
+              <a:rPr lang="it-IT" b="1" dirty="0"/>
+              <a:t>E2ED</a:t>
+            </a:r>
+            <a:r>
+              <a:rPr lang="it-IT" dirty="0"/>
+              <a:t>: end-to-end delay</a:t>
+            </a:r>
+          </a:p>
+          <a:p>
+            <a:r>
+              <a:rPr lang="it-IT" b="1" dirty="0"/>
+              <a:t>TTFT</a:t>
+            </a:r>
+            <a:r>
+              <a:rPr lang="it-IT" dirty="0"/>
+              <a:t>: time-to-first token</a:t>
+            </a:r>
+          </a:p>
+          <a:p>
+            <a:r>
+              <a:rPr lang="it-IT" b="1" dirty="0"/>
+              <a:t>TPOT</a:t>
+            </a:r>
+            <a:r>
+              <a:rPr lang="it-IT" dirty="0"/>
+              <a:t>: time-per-output-token</a:t>
+            </a:r>
+          </a:p>
+          <a:p>
+            <a:pPr lvl="1"/>
+            <a:r>
+              <a:rPr lang="it-IT" dirty="0"/>
+              <a:t>Average time spent to generate each output token (decode time / number of generated tokens)</a:t>
+            </a:r>
+          </a:p>
+          <a:p>
+            <a:pPr lvl="1"/>
+            <a:r>
+              <a:rPr lang="it-IT" dirty="0"/>
+              <a:t>Decode-phase metric</a:t>
+            </a:r>
+          </a:p>
+          <a:p>
+            <a:r>
+              <a:rPr lang="it-IT" dirty="0"/>
+              <a:t># of preemptions (the job already done is lost)</a:t>
+            </a:r>
+          </a:p>
+          <a:p>
+            <a:endParaRPr lang="en-US" dirty="0"/>
+          </a:p>
+        </p:txBody>
+      </p:sp>
+      <p:sp>
+        <p:nvSpPr>
+          <p:cNvPr id="4" name="Slide Number Placeholder 3">
+            <a:extLst>
+              <a:ext uri="{FF2B5EF4-FFF2-40B4-BE49-F238E27FC236}">
+                <a16:creationId xmlns:a16="http://schemas.microsoft.com/office/drawing/2014/main" id="{A181C1D1-159B-28FB-57D4-BA87A8B1C8CD}"/>
+              </a:ext>
+            </a:extLst>
+          </p:cNvPr>
+          <p:cNvSpPr>
+            <a:spLocks noGrp="1"/>
+          </p:cNvSpPr>
+          <p:nvPr>
+            <p:ph type="sldNum" sz="quarter" idx="12"/>
+          </p:nvPr>
+        </p:nvSpPr>
+        <p:spPr/>
+        <p:txBody>
+          <a:bodyPr/>
+          <a:lstStyle/>
+          <a:p>
+            <a:fld id="{77E0F69E-94E4-477D-9D2E-ABE325801752}" type="slidenum">
+              <a:rPr lang="it-IT" smtClean="0"/>
+              <a:t>14</a:t>
             </a:fld>
             <a:endParaRPr lang="it-IT"/>
           </a:p>
@@ -21056,7 +21436,7 @@
 </p:sld>
 </file>
 
-<file path=ppt/slides/slide12.xml><?xml version="1.0" encoding="utf-8"?>
+<file path=ppt/slides/slide15.xml><?xml version="1.0" encoding="utf-8"?>
 <p:sld xmlns:a="http://schemas.openxmlformats.org/drawingml/2006/main" xmlns:r="http://schemas.openxmlformats.org/officeDocument/2006/relationships" xmlns:p="http://schemas.openxmlformats.org/presentationml/2006/main">
   <p:cSld>
     <p:spTree>
@@ -22727,14 +23107,14 @@
           <a:p>
             <a:fld id="{77E0F69E-94E4-477D-9D2E-ABE325801752}" type="slidenum">
               <a:rPr lang="it-IT" smtClean="0"/>
-              <a:t>12</a:t>
+              <a:t>15</a:t>
             </a:fld>
             <a:endParaRPr lang="it-IT"/>
           </a:p>
         </p:txBody>
       </p:sp>
-      <mc:AlternateContent xmlns:mc="http://schemas.openxmlformats.org/markup-compatibility/2006">
-        <mc:Choice xmlns:a14="http://schemas.microsoft.com/office/drawing/2010/main" Requires="a14">
+      <mc:AlternateContent xmlns:mc="http://schemas.openxmlformats.org/markup-compatibility/2006" xmlns:a14="http://schemas.microsoft.com/office/drawing/2010/main">
+        <mc:Choice Requires="a14">
           <p:sp>
             <p:nvSpPr>
               <p:cNvPr id="6" name="TextBox 5">
@@ -22924,7 +23304,7 @@
             </p:txBody>
           </p:sp>
         </mc:Choice>
-        <mc:Fallback>
+        <mc:Fallback xmlns="">
           <p:sp>
             <p:nvSpPr>
               <p:cNvPr id="6" name="TextBox 5">
@@ -22982,7 +23362,7 @@
 </p:sld>
 </file>
 
-<file path=ppt/slides/slide13.xml><?xml version="1.0" encoding="utf-8"?>
+<file path=ppt/slides/slide16.xml><?xml version="1.0" encoding="utf-8"?>
 <p:sld xmlns:a="http://schemas.openxmlformats.org/drawingml/2006/main" xmlns:r="http://schemas.openxmlformats.org/officeDocument/2006/relationships" xmlns:p="http://schemas.openxmlformats.org/presentationml/2006/main">
   <p:cSld>
     <p:spTree>
@@ -23051,14 +23431,14 @@
           <a:p>
             <a:fld id="{77E0F69E-94E4-477D-9D2E-ABE325801752}" type="slidenum">
               <a:rPr lang="it-IT" smtClean="0"/>
-              <a:t>13</a:t>
+              <a:t>16</a:t>
             </a:fld>
             <a:endParaRPr lang="it-IT"/>
           </a:p>
         </p:txBody>
       </p:sp>
-      <mc:AlternateContent xmlns:mc="http://schemas.openxmlformats.org/markup-compatibility/2006">
-        <mc:Choice xmlns:a14="http://schemas.microsoft.com/office/drawing/2010/main" Requires="a14">
+      <mc:AlternateContent xmlns:mc="http://schemas.openxmlformats.org/markup-compatibility/2006" xmlns:a14="http://schemas.microsoft.com/office/drawing/2010/main">
+        <mc:Choice Requires="a14">
           <p:sp>
             <p:nvSpPr>
               <p:cNvPr id="5" name="TextBox 4">
@@ -23252,7 +23632,7 @@
             </p:txBody>
           </p:sp>
         </mc:Choice>
-        <mc:Fallback>
+        <mc:Fallback xmlns="">
           <p:sp>
             <p:nvSpPr>
               <p:cNvPr id="5" name="TextBox 4">
@@ -23312,7 +23692,7 @@
           <p:nvPr>
             <p:extLst>
               <p:ext uri="{D42A27DB-BD31-4B8C-83A1-F6EECF244321}">
-                <p14:modId xmlns:p14="http://schemas.microsoft.com/office/powerpoint/2010/main" val="3810061127"/>
+                <p14:modId xmlns:p14="http://schemas.microsoft.com/office/powerpoint/2010/main" val="2556032806"/>
               </p:ext>
             </p:extLst>
           </p:nvPr>
@@ -24988,7 +25368,7 @@
 </p:sld>
 </file>
 
-<file path=ppt/slides/slide14.xml><?xml version="1.0" encoding="utf-8"?>
+<file path=ppt/slides/slide17.xml><?xml version="1.0" encoding="utf-8"?>
 <p:sld xmlns:a="http://schemas.openxmlformats.org/drawingml/2006/main" xmlns:r="http://schemas.openxmlformats.org/officeDocument/2006/relationships" xmlns:p="http://schemas.openxmlformats.org/presentationml/2006/main">
   <p:cSld>
     <p:spTree>
@@ -25057,14 +25437,14 @@
           <a:p>
             <a:fld id="{77E0F69E-94E4-477D-9D2E-ABE325801752}" type="slidenum">
               <a:rPr lang="it-IT" smtClean="0"/>
-              <a:t>14</a:t>
+              <a:t>17</a:t>
             </a:fld>
             <a:endParaRPr lang="it-IT"/>
           </a:p>
         </p:txBody>
       </p:sp>
-      <mc:AlternateContent xmlns:mc="http://schemas.openxmlformats.org/markup-compatibility/2006">
-        <mc:Choice xmlns:a14="http://schemas.microsoft.com/office/drawing/2010/main" Requires="a14">
+      <mc:AlternateContent xmlns:mc="http://schemas.openxmlformats.org/markup-compatibility/2006" xmlns:a14="http://schemas.microsoft.com/office/drawing/2010/main">
+        <mc:Choice Requires="a14">
           <p:sp>
             <p:nvSpPr>
               <p:cNvPr id="6" name="TextBox 5">
@@ -25166,7 +25546,7 @@
             </p:txBody>
           </p:sp>
         </mc:Choice>
-        <mc:Fallback>
+        <mc:Fallback xmlns="">
           <p:sp>
             <p:nvSpPr>
               <p:cNvPr id="6" name="TextBox 5">
@@ -25226,13 +25606,13 @@
           <p:nvPr>
             <p:extLst>
               <p:ext uri="{D42A27DB-BD31-4B8C-83A1-F6EECF244321}">
-                <p14:modId xmlns:p14="http://schemas.microsoft.com/office/powerpoint/2010/main" val="2988910245"/>
+                <p14:modId xmlns:p14="http://schemas.microsoft.com/office/powerpoint/2010/main" val="828858203"/>
               </p:ext>
             </p:extLst>
           </p:nvPr>
         </p:nvGraphicFramePr>
         <p:xfrm>
-          <a:off x="1372298" y="2209777"/>
+          <a:off x="1354352" y="2267010"/>
           <a:ext cx="9387442" cy="3395086"/>
         </p:xfrm>
         <a:graphic>
@@ -25602,7 +25982,7 @@
                         <a:buNone/>
                       </a:pPr>
                       <a:r>
-                        <a:rPr lang="en-US" sz="1400"/>
+                        <a:rPr lang="en-US" sz="1400" dirty="0"/>
                         <a:t>80.8230</a:t>
                       </a:r>
                     </a:p>
@@ -25867,7 +26247,7 @@
                         <a:buNone/>
                       </a:pPr>
                       <a:r>
-                        <a:rPr lang="en-US" sz="1400"/>
+                        <a:rPr lang="en-US" sz="1400" dirty="0"/>
                         <a:t>70.6407</a:t>
                       </a:r>
                     </a:p>
@@ -25933,7 +26313,7 @@
                         <a:buNone/>
                       </a:pPr>
                       <a:r>
-                        <a:rPr lang="en-US" sz="1400"/>
+                        <a:rPr lang="en-US" sz="1400" dirty="0"/>
                         <a:t>77.5347</a:t>
                       </a:r>
                     </a:p>
@@ -26096,7 +26476,7 @@
                         <a:buNone/>
                       </a:pPr>
                       <a:r>
-                        <a:rPr lang="en-US" sz="1400"/>
+                        <a:rPr lang="en-US" sz="1400" dirty="0"/>
                         <a:t>0.3377</a:t>
                       </a:r>
                     </a:p>
@@ -26325,7 +26705,7 @@
                         <a:buNone/>
                       </a:pPr>
                       <a:r>
-                        <a:rPr lang="en-US" sz="1400"/>
+                        <a:rPr lang="en-US" sz="1400" dirty="0"/>
                         <a:t>8.8957</a:t>
                       </a:r>
                     </a:p>
@@ -26421,7 +26801,7 @@
                         <a:buNone/>
                       </a:pPr>
                       <a:r>
-                        <a:rPr lang="en-US" sz="1400"/>
+                        <a:rPr lang="en-US" sz="1400" dirty="0"/>
                         <a:t>10.2903</a:t>
                       </a:r>
                     </a:p>
@@ -26451,7 +26831,7 @@
                         <a:buNone/>
                       </a:pPr>
                       <a:r>
-                        <a:rPr lang="en-US" sz="1400"/>
+                        <a:rPr lang="en-US" sz="1400" dirty="0"/>
                         <a:t>10.2903</a:t>
                       </a:r>
                     </a:p>
@@ -26847,6 +27227,58 @@
           </a:p>
         </p:txBody>
       </p:sp>
+      <p:sp>
+        <p:nvSpPr>
+          <p:cNvPr id="10" name="Rectangle: Diagonal Corners Rounded 9">
+            <a:extLst>
+              <a:ext uri="{FF2B5EF4-FFF2-40B4-BE49-F238E27FC236}">
+                <a16:creationId xmlns:a16="http://schemas.microsoft.com/office/drawing/2014/main" id="{270ED419-86CB-3717-48B2-C7695C4203D9}"/>
+              </a:ext>
+            </a:extLst>
+          </p:cNvPr>
+          <p:cNvSpPr/>
+          <p:nvPr/>
+        </p:nvSpPr>
+        <p:spPr>
+          <a:xfrm>
+            <a:off x="9467675" y="5519990"/>
+            <a:ext cx="2724325" cy="568424"/>
+          </a:xfrm>
+          <a:prstGeom prst="round2DiagRect">
+            <a:avLst/>
+          </a:prstGeom>
+          <a:ln>
+            <a:noFill/>
+          </a:ln>
+        </p:spPr>
+        <p:style>
+          <a:lnRef idx="2">
+            <a:schemeClr val="accent1">
+              <a:shade val="15000"/>
+            </a:schemeClr>
+          </a:lnRef>
+          <a:fillRef idx="1">
+            <a:schemeClr val="accent1"/>
+          </a:fillRef>
+          <a:effectRef idx="0">
+            <a:schemeClr val="accent1"/>
+          </a:effectRef>
+          <a:fontRef idx="minor">
+            <a:schemeClr val="lt1"/>
+          </a:fontRef>
+        </p:style>
+        <p:txBody>
+          <a:bodyPr rtlCol="0" anchor="ctr"/>
+          <a:lstStyle/>
+          <a:p>
+            <a:pPr algn="ctr"/>
+            <a:r>
+              <a:rPr lang="it-IT" dirty="0"/>
+              <a:t>Head of line blocking</a:t>
+            </a:r>
+          </a:p>
+        </p:txBody>
+      </p:sp>
     </p:spTree>
     <p:extLst>
       <p:ext uri="{BB962C8B-B14F-4D97-AF65-F5344CB8AC3E}">
@@ -27117,7 +27549,7 @@
           <p:cNvPr id="2" name="Title 1">
             <a:extLst>
               <a:ext uri="{FF2B5EF4-FFF2-40B4-BE49-F238E27FC236}">
-                <a16:creationId xmlns:a16="http://schemas.microsoft.com/office/drawing/2014/main" id="{ACC375DF-E32D-FFB5-C032-F946EFF0D80B}"/>
+                <a16:creationId xmlns:a16="http://schemas.microsoft.com/office/drawing/2014/main" id="{70184C53-0F01-3D34-FADE-D095D9546978}"/>
               </a:ext>
             </a:extLst>
           </p:cNvPr>
@@ -27135,7 +27567,7 @@
           <a:p>
             <a:r>
               <a:rPr lang="it-IT" dirty="0"/>
-              <a:t>Continuous Batching</a:t>
+              <a:t>Attention ? Explanation</a:t>
             </a:r>
             <a:endParaRPr lang="en-US" dirty="0"/>
           </a:p>
@@ -27146,7 +27578,7 @@
           <p:cNvPr id="3" name="Content Placeholder 2">
             <a:extLst>
               <a:ext uri="{FF2B5EF4-FFF2-40B4-BE49-F238E27FC236}">
-                <a16:creationId xmlns:a16="http://schemas.microsoft.com/office/drawing/2014/main" id="{422BB488-4995-F745-2721-9171DC561330}"/>
+                <a16:creationId xmlns:a16="http://schemas.microsoft.com/office/drawing/2014/main" id="{38FD989F-EDFD-22CD-7465-B36C5EF24048}"/>
               </a:ext>
             </a:extLst>
           </p:cNvPr>
@@ -27171,7 +27603,7 @@
           <p:cNvPr id="4" name="Slide Number Placeholder 3">
             <a:extLst>
               <a:ext uri="{FF2B5EF4-FFF2-40B4-BE49-F238E27FC236}">
-                <a16:creationId xmlns:a16="http://schemas.microsoft.com/office/drawing/2014/main" id="{5CA87F1D-C20D-52F7-0930-FDA1E9E6CB0D}"/>
+                <a16:creationId xmlns:a16="http://schemas.microsoft.com/office/drawing/2014/main" id="{7A4ADB10-DA74-71D1-08F7-23A37E98BF98}"/>
               </a:ext>
             </a:extLst>
           </p:cNvPr>
@@ -27198,7 +27630,7 @@
     </p:spTree>
     <p:extLst>
       <p:ext uri="{BB962C8B-B14F-4D97-AF65-F5344CB8AC3E}">
-        <p14:creationId xmlns:p14="http://schemas.microsoft.com/office/powerpoint/2010/main" val="1642632419"/>
+        <p14:creationId xmlns:p14="http://schemas.microsoft.com/office/powerpoint/2010/main" val="4092397609"/>
       </p:ext>
     </p:extLst>
   </p:cSld>
@@ -27230,7 +27662,7 @@
           <p:cNvPr id="2" name="Title 1">
             <a:extLst>
               <a:ext uri="{FF2B5EF4-FFF2-40B4-BE49-F238E27FC236}">
-                <a16:creationId xmlns:a16="http://schemas.microsoft.com/office/drawing/2014/main" id="{2041784B-AE1E-44E7-C592-EAECDB05DBB4}"/>
+                <a16:creationId xmlns:a16="http://schemas.microsoft.com/office/drawing/2014/main" id="{ACC375DF-E32D-FFB5-C032-F946EFF0D80B}"/>
               </a:ext>
             </a:extLst>
           </p:cNvPr>
@@ -27248,7 +27680,7 @@
           <a:p>
             <a:r>
               <a:rPr lang="it-IT" dirty="0"/>
-              <a:t>The Role of Batches</a:t>
+              <a:t>Continuous Batching</a:t>
             </a:r>
             <a:endParaRPr lang="en-US" dirty="0"/>
           </a:p>
@@ -27259,7 +27691,7 @@
           <p:cNvPr id="3" name="Content Placeholder 2">
             <a:extLst>
               <a:ext uri="{FF2B5EF4-FFF2-40B4-BE49-F238E27FC236}">
-                <a16:creationId xmlns:a16="http://schemas.microsoft.com/office/drawing/2014/main" id="{B0384983-308C-ABD1-FE1A-347169716798}"/>
+                <a16:creationId xmlns:a16="http://schemas.microsoft.com/office/drawing/2014/main" id="{422BB488-4995-F745-2721-9171DC561330}"/>
               </a:ext>
             </a:extLst>
           </p:cNvPr>
@@ -27284,7 +27716,7 @@
           <p:cNvPr id="4" name="Slide Number Placeholder 3">
             <a:extLst>
               <a:ext uri="{FF2B5EF4-FFF2-40B4-BE49-F238E27FC236}">
-                <a16:creationId xmlns:a16="http://schemas.microsoft.com/office/drawing/2014/main" id="{ECE30592-AE0D-77A3-5C7A-04376BD90F5B}"/>
+                <a16:creationId xmlns:a16="http://schemas.microsoft.com/office/drawing/2014/main" id="{5CA87F1D-C20D-52F7-0930-FDA1E9E6CB0D}"/>
               </a:ext>
             </a:extLst>
           </p:cNvPr>
@@ -27311,7 +27743,7 @@
     </p:spTree>
     <p:extLst>
       <p:ext uri="{BB962C8B-B14F-4D97-AF65-F5344CB8AC3E}">
-        <p14:creationId xmlns:p14="http://schemas.microsoft.com/office/powerpoint/2010/main" val="3915914882"/>
+        <p14:creationId xmlns:p14="http://schemas.microsoft.com/office/powerpoint/2010/main" val="1642632419"/>
       </p:ext>
     </p:extLst>
   </p:cSld>
@@ -27343,7 +27775,7 @@
           <p:cNvPr id="2" name="Title 1">
             <a:extLst>
               <a:ext uri="{FF2B5EF4-FFF2-40B4-BE49-F238E27FC236}">
-                <a16:creationId xmlns:a16="http://schemas.microsoft.com/office/drawing/2014/main" id="{7236E475-A05E-6CCD-E77A-FDF32E569ED6}"/>
+                <a16:creationId xmlns:a16="http://schemas.microsoft.com/office/drawing/2014/main" id="{2041784B-AE1E-44E7-C592-EAECDB05DBB4}"/>
               </a:ext>
             </a:extLst>
           </p:cNvPr>
@@ -27361,14 +27793,127 @@
           <a:p>
             <a:r>
               <a:rPr lang="it-IT" dirty="0"/>
+              <a:t>The Role of Batches</a:t>
+            </a:r>
+            <a:endParaRPr lang="en-US" dirty="0"/>
+          </a:p>
+        </p:txBody>
+      </p:sp>
+      <p:sp>
+        <p:nvSpPr>
+          <p:cNvPr id="3" name="Content Placeholder 2">
+            <a:extLst>
+              <a:ext uri="{FF2B5EF4-FFF2-40B4-BE49-F238E27FC236}">
+                <a16:creationId xmlns:a16="http://schemas.microsoft.com/office/drawing/2014/main" id="{B0384983-308C-ABD1-FE1A-347169716798}"/>
+              </a:ext>
+            </a:extLst>
+          </p:cNvPr>
+          <p:cNvSpPr>
+            <a:spLocks noGrp="1"/>
+          </p:cNvSpPr>
+          <p:nvPr>
+            <p:ph idx="1"/>
+          </p:nvPr>
+        </p:nvSpPr>
+        <p:spPr/>
+        <p:txBody>
+          <a:bodyPr/>
+          <a:lstStyle/>
+          <a:p>
+            <a:endParaRPr lang="en-US"/>
+          </a:p>
+        </p:txBody>
+      </p:sp>
+      <p:sp>
+        <p:nvSpPr>
+          <p:cNvPr id="4" name="Slide Number Placeholder 3">
+            <a:extLst>
+              <a:ext uri="{FF2B5EF4-FFF2-40B4-BE49-F238E27FC236}">
+                <a16:creationId xmlns:a16="http://schemas.microsoft.com/office/drawing/2014/main" id="{ECE30592-AE0D-77A3-5C7A-04376BD90F5B}"/>
+              </a:ext>
+            </a:extLst>
+          </p:cNvPr>
+          <p:cNvSpPr>
+            <a:spLocks noGrp="1"/>
+          </p:cNvSpPr>
+          <p:nvPr>
+            <p:ph type="sldNum" sz="quarter" idx="12"/>
+          </p:nvPr>
+        </p:nvSpPr>
+        <p:spPr/>
+        <p:txBody>
+          <a:bodyPr/>
+          <a:lstStyle/>
+          <a:p>
+            <a:fld id="{77E0F69E-94E4-477D-9D2E-ABE325801752}" type="slidenum">
+              <a:rPr lang="it-IT" smtClean="0"/>
+              <a:t>6</a:t>
+            </a:fld>
+            <a:endParaRPr lang="it-IT"/>
+          </a:p>
+        </p:txBody>
+      </p:sp>
+    </p:spTree>
+    <p:extLst>
+      <p:ext uri="{BB962C8B-B14F-4D97-AF65-F5344CB8AC3E}">
+        <p14:creationId xmlns:p14="http://schemas.microsoft.com/office/powerpoint/2010/main" val="3915914882"/>
+      </p:ext>
+    </p:extLst>
+  </p:cSld>
+  <p:clrMapOvr>
+    <a:masterClrMapping/>
+  </p:clrMapOvr>
+</p:sld>
+</file>
+
+<file path=ppt/slides/slide7.xml><?xml version="1.0" encoding="utf-8"?>
+<p:sld xmlns:a="http://schemas.openxmlformats.org/drawingml/2006/main" xmlns:r="http://schemas.openxmlformats.org/officeDocument/2006/relationships" xmlns:p="http://schemas.openxmlformats.org/presentationml/2006/main">
+  <p:cSld>
+    <p:spTree>
+      <p:nvGrpSpPr>
+        <p:cNvPr id="1" name=""/>
+        <p:cNvGrpSpPr/>
+        <p:nvPr/>
+      </p:nvGrpSpPr>
+      <p:grpSpPr>
+        <a:xfrm>
+          <a:off x="0" y="0"/>
+          <a:ext cx="0" cy="0"/>
+          <a:chOff x="0" y="0"/>
+          <a:chExt cx="0" cy="0"/>
+        </a:xfrm>
+      </p:grpSpPr>
+      <p:sp>
+        <p:nvSpPr>
+          <p:cNvPr id="2" name="Title 1">
+            <a:extLst>
+              <a:ext uri="{FF2B5EF4-FFF2-40B4-BE49-F238E27FC236}">
+                <a16:creationId xmlns:a16="http://schemas.microsoft.com/office/drawing/2014/main" id="{7236E475-A05E-6CCD-E77A-FDF32E569ED6}"/>
+              </a:ext>
+            </a:extLst>
+          </p:cNvPr>
+          <p:cNvSpPr>
+            <a:spLocks noGrp="1"/>
+          </p:cNvSpPr>
+          <p:nvPr>
+            <p:ph type="title"/>
+          </p:nvPr>
+        </p:nvSpPr>
+        <p:spPr/>
+        <p:txBody>
+          <a:bodyPr/>
+          <a:lstStyle/>
+          <a:p>
+            <a:r>
+              <a:rPr lang="it-IT" dirty="0"/>
               <a:t>Chunked Prefill</a:t>
             </a:r>
             <a:endParaRPr lang="en-US" dirty="0"/>
           </a:p>
         </p:txBody>
       </p:sp>
-      <mc:AlternateContent xmlns:mc="http://schemas.openxmlformats.org/markup-compatibility/2006">
-        <mc:Choice xmlns:a14="http://schemas.microsoft.com/office/drawing/2010/main" Requires="a14">
+      <mc:AlternateContent xmlns:mc="http://schemas.openxmlformats.org/markup-compatibility/2006" xmlns:a14="http://schemas.microsoft.com/office/drawing/2010/main">
+        <mc:Choice Requires="a14">
           <p:sp>
             <p:nvSpPr>
               <p:cNvPr id="3" name="Content Placeholder 2">
@@ -27613,7 +28158,7 @@
             </p:txBody>
           </p:sp>
         </mc:Choice>
-        <mc:Fallback>
+        <mc:Fallback xmlns="">
           <p:sp>
             <p:nvSpPr>
               <p:cNvPr id="3" name="Content Placeholder 2">
@@ -27676,7 +28221,7 @@
           <a:p>
             <a:fld id="{77E0F69E-94E4-477D-9D2E-ABE325801752}" type="slidenum">
               <a:rPr lang="it-IT" smtClean="0"/>
-              <a:t>6</a:t>
+              <a:t>7</a:t>
             </a:fld>
             <a:endParaRPr lang="it-IT"/>
           </a:p>
@@ -27686,197 +28231,6 @@
     <p:extLst>
       <p:ext uri="{BB962C8B-B14F-4D97-AF65-F5344CB8AC3E}">
         <p14:creationId xmlns:p14="http://schemas.microsoft.com/office/powerpoint/2010/main" val="1006789659"/>
-      </p:ext>
-    </p:extLst>
-  </p:cSld>
-  <p:clrMapOvr>
-    <a:masterClrMapping/>
-  </p:clrMapOvr>
-</p:sld>
-</file>
-
-<file path=ppt/slides/slide7.xml><?xml version="1.0" encoding="utf-8"?>
-<p:sld xmlns:a="http://schemas.openxmlformats.org/drawingml/2006/main" xmlns:r="http://schemas.openxmlformats.org/officeDocument/2006/relationships" xmlns:p="http://schemas.openxmlformats.org/presentationml/2006/main">
-  <p:cSld>
-    <p:spTree>
-      <p:nvGrpSpPr>
-        <p:cNvPr id="1" name=""/>
-        <p:cNvGrpSpPr/>
-        <p:nvPr/>
-      </p:nvGrpSpPr>
-      <p:grpSpPr>
-        <a:xfrm>
-          <a:off x="0" y="0"/>
-          <a:ext cx="0" cy="0"/>
-          <a:chOff x="0" y="0"/>
-          <a:chExt cx="0" cy="0"/>
-        </a:xfrm>
-      </p:grpSpPr>
-      <p:sp>
-        <p:nvSpPr>
-          <p:cNvPr id="2" name="Title 1">
-            <a:extLst>
-              <a:ext uri="{FF2B5EF4-FFF2-40B4-BE49-F238E27FC236}">
-                <a16:creationId xmlns:a16="http://schemas.microsoft.com/office/drawing/2014/main" id="{9D8AD51C-052C-9F83-560F-433668D40007}"/>
-              </a:ext>
-            </a:extLst>
-          </p:cNvPr>
-          <p:cNvSpPr>
-            <a:spLocks noGrp="1"/>
-          </p:cNvSpPr>
-          <p:nvPr>
-            <p:ph type="title"/>
-          </p:nvPr>
-        </p:nvSpPr>
-        <p:spPr/>
-        <p:txBody>
-          <a:bodyPr/>
-          <a:lstStyle/>
-          <a:p>
-            <a:r>
-              <a:rPr lang="it-IT" dirty="0"/>
-              <a:t>Chunked Prefill cont.</a:t>
-            </a:r>
-            <a:endParaRPr lang="en-US" dirty="0"/>
-          </a:p>
-        </p:txBody>
-      </p:sp>
-      <p:sp>
-        <p:nvSpPr>
-          <p:cNvPr id="3" name="Content Placeholder 2">
-            <a:extLst>
-              <a:ext uri="{FF2B5EF4-FFF2-40B4-BE49-F238E27FC236}">
-                <a16:creationId xmlns:a16="http://schemas.microsoft.com/office/drawing/2014/main" id="{96518275-C2D0-842A-FB16-F091D6B746C4}"/>
-              </a:ext>
-            </a:extLst>
-          </p:cNvPr>
-          <p:cNvSpPr>
-            <a:spLocks noGrp="1"/>
-          </p:cNvSpPr>
-          <p:nvPr>
-            <p:ph idx="1"/>
-          </p:nvPr>
-        </p:nvSpPr>
-        <p:spPr/>
-        <p:txBody>
-          <a:bodyPr/>
-          <a:lstStyle/>
-          <a:p>
-            <a:r>
-              <a:rPr lang="it-IT" i="1" dirty="0"/>
-              <a:t>Why is it?</a:t>
-            </a:r>
-          </a:p>
-          <a:p>
-            <a:pPr lvl="1"/>
-            <a:r>
-              <a:rPr lang="it-IT" dirty="0"/>
-              <a:t>Avoid GPU Out Of Memory (</a:t>
-            </a:r>
-            <a:r>
-              <a:rPr lang="it-IT" b="1" dirty="0"/>
-              <a:t>OOM</a:t>
-            </a:r>
-            <a:r>
-              <a:rPr lang="it-IT" dirty="0"/>
-              <a:t>)</a:t>
-            </a:r>
-          </a:p>
-          <a:p>
-            <a:pPr lvl="1"/>
-            <a:r>
-              <a:rPr lang="it-IT" dirty="0"/>
-              <a:t>Avoid </a:t>
-            </a:r>
-            <a:r>
-              <a:rPr lang="it-IT" b="1" dirty="0"/>
-              <a:t>activation-memory blowups </a:t>
-            </a:r>
-            <a:r>
-              <a:rPr lang="it-IT" dirty="0"/>
-              <a:t>(prefill over many tokens creates large temporary activations; compute-heavy)</a:t>
-            </a:r>
-          </a:p>
-          <a:p>
-            <a:pPr lvl="2"/>
-            <a:r>
-              <a:rPr lang="it-IT" dirty="0"/>
-              <a:t>Intermediate activation tensors during the </a:t>
-            </a:r>
-            <a:r>
-              <a:rPr lang="it-IT" i="1" dirty="0"/>
-              <a:t>forward</a:t>
-            </a:r>
-            <a:r>
-              <a:rPr lang="it-IT" dirty="0"/>
-              <a:t> pass</a:t>
-            </a:r>
-          </a:p>
-          <a:p>
-            <a:pPr lvl="2"/>
-            <a:r>
-              <a:rPr lang="it-IT" dirty="0"/>
-              <a:t>Temp copies of Q, K, V during attention computation</a:t>
-            </a:r>
-          </a:p>
-          <a:p>
-            <a:pPr lvl="1"/>
-            <a:r>
-              <a:rPr lang="it-IT" dirty="0"/>
-              <a:t>Balance between prefill and decode</a:t>
-            </a:r>
-          </a:p>
-          <a:p>
-            <a:pPr lvl="2"/>
-            <a:r>
-              <a:rPr lang="it-IT" dirty="0"/>
-              <a:t>With continuous batching, prefill and decode are mixed together, if prefill can consume arbitrarily large tokens </a:t>
-            </a:r>
-            <a:r>
-              <a:rPr lang="en-US" b="1" dirty="0"/>
-              <a:t>decode requests may wait </a:t>
-            </a:r>
-            <a:r>
-              <a:rPr lang="en-US" dirty="0"/>
-              <a:t>behind a huge prompt pass</a:t>
-            </a:r>
-            <a:endParaRPr lang="it-IT" dirty="0"/>
-          </a:p>
-        </p:txBody>
-      </p:sp>
-      <p:sp>
-        <p:nvSpPr>
-          <p:cNvPr id="4" name="Slide Number Placeholder 3">
-            <a:extLst>
-              <a:ext uri="{FF2B5EF4-FFF2-40B4-BE49-F238E27FC236}">
-                <a16:creationId xmlns:a16="http://schemas.microsoft.com/office/drawing/2014/main" id="{FC87D0FF-73CA-CCF0-8D50-204B4A6A62C6}"/>
-              </a:ext>
-            </a:extLst>
-          </p:cNvPr>
-          <p:cNvSpPr>
-            <a:spLocks noGrp="1"/>
-          </p:cNvSpPr>
-          <p:nvPr>
-            <p:ph type="sldNum" sz="quarter" idx="12"/>
-          </p:nvPr>
-        </p:nvSpPr>
-        <p:spPr/>
-        <p:txBody>
-          <a:bodyPr/>
-          <a:lstStyle/>
-          <a:p>
-            <a:fld id="{77E0F69E-94E4-477D-9D2E-ABE325801752}" type="slidenum">
-              <a:rPr lang="it-IT" smtClean="0"/>
-              <a:t>7</a:t>
-            </a:fld>
-            <a:endParaRPr lang="it-IT"/>
-          </a:p>
-        </p:txBody>
-      </p:sp>
-    </p:spTree>
-    <p:extLst>
-      <p:ext uri="{BB962C8B-B14F-4D97-AF65-F5344CB8AC3E}">
-        <p14:creationId xmlns:p14="http://schemas.microsoft.com/office/powerpoint/2010/main" val="746553745"/>
       </p:ext>
     </p:extLst>
   </p:cSld>
@@ -27908,7 +28262,7 @@
           <p:cNvPr id="2" name="Title 1">
             <a:extLst>
               <a:ext uri="{FF2B5EF4-FFF2-40B4-BE49-F238E27FC236}">
-                <a16:creationId xmlns:a16="http://schemas.microsoft.com/office/drawing/2014/main" id="{14B88065-79C9-5304-3DE0-98F6D17D33BD}"/>
+                <a16:creationId xmlns:a16="http://schemas.microsoft.com/office/drawing/2014/main" id="{9D8AD51C-052C-9F83-560F-433668D40007}"/>
               </a:ext>
             </a:extLst>
           </p:cNvPr>
@@ -27932,8 +28286,199 @@
           </a:p>
         </p:txBody>
       </p:sp>
-      <mc:AlternateContent xmlns:mc="http://schemas.openxmlformats.org/markup-compatibility/2006">
-        <mc:Choice xmlns:a14="http://schemas.microsoft.com/office/drawing/2010/main" Requires="a14">
+      <p:sp>
+        <p:nvSpPr>
+          <p:cNvPr id="3" name="Content Placeholder 2">
+            <a:extLst>
+              <a:ext uri="{FF2B5EF4-FFF2-40B4-BE49-F238E27FC236}">
+                <a16:creationId xmlns:a16="http://schemas.microsoft.com/office/drawing/2014/main" id="{96518275-C2D0-842A-FB16-F091D6B746C4}"/>
+              </a:ext>
+            </a:extLst>
+          </p:cNvPr>
+          <p:cNvSpPr>
+            <a:spLocks noGrp="1"/>
+          </p:cNvSpPr>
+          <p:nvPr>
+            <p:ph idx="1"/>
+          </p:nvPr>
+        </p:nvSpPr>
+        <p:spPr/>
+        <p:txBody>
+          <a:bodyPr/>
+          <a:lstStyle/>
+          <a:p>
+            <a:r>
+              <a:rPr lang="it-IT" i="1" dirty="0"/>
+              <a:t>Why is it?</a:t>
+            </a:r>
+          </a:p>
+          <a:p>
+            <a:pPr lvl="1"/>
+            <a:r>
+              <a:rPr lang="it-IT" dirty="0"/>
+              <a:t>Avoid GPU Out Of Memory (</a:t>
+            </a:r>
+            <a:r>
+              <a:rPr lang="it-IT" b="1" dirty="0"/>
+              <a:t>OOM</a:t>
+            </a:r>
+            <a:r>
+              <a:rPr lang="it-IT" dirty="0"/>
+              <a:t>)</a:t>
+            </a:r>
+          </a:p>
+          <a:p>
+            <a:pPr lvl="1"/>
+            <a:r>
+              <a:rPr lang="it-IT" dirty="0"/>
+              <a:t>Avoid </a:t>
+            </a:r>
+            <a:r>
+              <a:rPr lang="it-IT" b="1" dirty="0"/>
+              <a:t>activation-memory blowups </a:t>
+            </a:r>
+            <a:r>
+              <a:rPr lang="it-IT" dirty="0"/>
+              <a:t>(prefill over many tokens creates large temporary activations; compute-heavy)</a:t>
+            </a:r>
+          </a:p>
+          <a:p>
+            <a:pPr lvl="2"/>
+            <a:r>
+              <a:rPr lang="it-IT" dirty="0"/>
+              <a:t>Intermediate activation tensors during the </a:t>
+            </a:r>
+            <a:r>
+              <a:rPr lang="it-IT" i="1" dirty="0"/>
+              <a:t>forward</a:t>
+            </a:r>
+            <a:r>
+              <a:rPr lang="it-IT" dirty="0"/>
+              <a:t> pass</a:t>
+            </a:r>
+          </a:p>
+          <a:p>
+            <a:pPr lvl="2"/>
+            <a:r>
+              <a:rPr lang="it-IT" dirty="0"/>
+              <a:t>Temp copies of Q, K, V during attention computation</a:t>
+            </a:r>
+          </a:p>
+          <a:p>
+            <a:pPr lvl="1"/>
+            <a:r>
+              <a:rPr lang="it-IT" dirty="0"/>
+              <a:t>Balance between prefill and decode</a:t>
+            </a:r>
+          </a:p>
+          <a:p>
+            <a:pPr lvl="2"/>
+            <a:r>
+              <a:rPr lang="it-IT" dirty="0"/>
+              <a:t>With continuous batching, prefill and decode are mixed together, if prefill can consume arbitrarily large tokens </a:t>
+            </a:r>
+            <a:r>
+              <a:rPr lang="en-US" b="1" dirty="0"/>
+              <a:t>decode requests may wait </a:t>
+            </a:r>
+            <a:r>
+              <a:rPr lang="en-US" dirty="0"/>
+              <a:t>behind a huge prompt pass</a:t>
+            </a:r>
+            <a:endParaRPr lang="it-IT" dirty="0"/>
+          </a:p>
+        </p:txBody>
+      </p:sp>
+      <p:sp>
+        <p:nvSpPr>
+          <p:cNvPr id="4" name="Slide Number Placeholder 3">
+            <a:extLst>
+              <a:ext uri="{FF2B5EF4-FFF2-40B4-BE49-F238E27FC236}">
+                <a16:creationId xmlns:a16="http://schemas.microsoft.com/office/drawing/2014/main" id="{FC87D0FF-73CA-CCF0-8D50-204B4A6A62C6}"/>
+              </a:ext>
+            </a:extLst>
+          </p:cNvPr>
+          <p:cNvSpPr>
+            <a:spLocks noGrp="1"/>
+          </p:cNvSpPr>
+          <p:nvPr>
+            <p:ph type="sldNum" sz="quarter" idx="12"/>
+          </p:nvPr>
+        </p:nvSpPr>
+        <p:spPr/>
+        <p:txBody>
+          <a:bodyPr/>
+          <a:lstStyle/>
+          <a:p>
+            <a:fld id="{77E0F69E-94E4-477D-9D2E-ABE325801752}" type="slidenum">
+              <a:rPr lang="it-IT" smtClean="0"/>
+              <a:t>8</a:t>
+            </a:fld>
+            <a:endParaRPr lang="it-IT"/>
+          </a:p>
+        </p:txBody>
+      </p:sp>
+    </p:spTree>
+    <p:extLst>
+      <p:ext uri="{BB962C8B-B14F-4D97-AF65-F5344CB8AC3E}">
+        <p14:creationId xmlns:p14="http://schemas.microsoft.com/office/powerpoint/2010/main" val="746553745"/>
+      </p:ext>
+    </p:extLst>
+  </p:cSld>
+  <p:clrMapOvr>
+    <a:masterClrMapping/>
+  </p:clrMapOvr>
+</p:sld>
+</file>
+
+<file path=ppt/slides/slide9.xml><?xml version="1.0" encoding="utf-8"?>
+<p:sld xmlns:a="http://schemas.openxmlformats.org/drawingml/2006/main" xmlns:r="http://schemas.openxmlformats.org/officeDocument/2006/relationships" xmlns:p="http://schemas.openxmlformats.org/presentationml/2006/main">
+  <p:cSld>
+    <p:spTree>
+      <p:nvGrpSpPr>
+        <p:cNvPr id="1" name=""/>
+        <p:cNvGrpSpPr/>
+        <p:nvPr/>
+      </p:nvGrpSpPr>
+      <p:grpSpPr>
+        <a:xfrm>
+          <a:off x="0" y="0"/>
+          <a:ext cx="0" cy="0"/>
+          <a:chOff x="0" y="0"/>
+          <a:chExt cx="0" cy="0"/>
+        </a:xfrm>
+      </p:grpSpPr>
+      <p:sp>
+        <p:nvSpPr>
+          <p:cNvPr id="2" name="Title 1">
+            <a:extLst>
+              <a:ext uri="{FF2B5EF4-FFF2-40B4-BE49-F238E27FC236}">
+                <a16:creationId xmlns:a16="http://schemas.microsoft.com/office/drawing/2014/main" id="{14B88065-79C9-5304-3DE0-98F6D17D33BD}"/>
+              </a:ext>
+            </a:extLst>
+          </p:cNvPr>
+          <p:cNvSpPr>
+            <a:spLocks noGrp="1"/>
+          </p:cNvSpPr>
+          <p:nvPr>
+            <p:ph type="title"/>
+          </p:nvPr>
+        </p:nvSpPr>
+        <p:spPr/>
+        <p:txBody>
+          <a:bodyPr/>
+          <a:lstStyle/>
+          <a:p>
+            <a:r>
+              <a:rPr lang="it-IT" dirty="0"/>
+              <a:t>Chunked Prefill cont.</a:t>
+            </a:r>
+            <a:endParaRPr lang="en-US" dirty="0"/>
+          </a:p>
+        </p:txBody>
+      </p:sp>
+      <mc:AlternateContent xmlns:mc="http://schemas.openxmlformats.org/markup-compatibility/2006" xmlns:a14="http://schemas.microsoft.com/office/drawing/2010/main">
+        <mc:Choice Requires="a14">
           <p:sp>
             <p:nvSpPr>
               <p:cNvPr id="3" name="Content Placeholder 2">
@@ -28080,7 +28625,7 @@
             </p:txBody>
           </p:sp>
         </mc:Choice>
-        <mc:Fallback>
+        <mc:Fallback xmlns="">
           <p:sp>
             <p:nvSpPr>
               <p:cNvPr id="3" name="Content Placeholder 2">
@@ -28143,7 +28688,7 @@
           <a:p>
             <a:fld id="{77E0F69E-94E4-477D-9D2E-ABE325801752}" type="slidenum">
               <a:rPr lang="it-IT" smtClean="0"/>
-              <a:t>8</a:t>
+              <a:t>9</a:t>
             </a:fld>
             <a:endParaRPr lang="it-IT"/>
           </a:p>
@@ -28153,115 +28698,6 @@
     <p:extLst>
       <p:ext uri="{BB962C8B-B14F-4D97-AF65-F5344CB8AC3E}">
         <p14:creationId xmlns:p14="http://schemas.microsoft.com/office/powerpoint/2010/main" val="447962915"/>
-      </p:ext>
-    </p:extLst>
-  </p:cSld>
-  <p:clrMapOvr>
-    <a:masterClrMapping/>
-  </p:clrMapOvr>
-</p:sld>
-</file>
-
-<file path=ppt/slides/slide9.xml><?xml version="1.0" encoding="utf-8"?>
-<p:sld xmlns:a="http://schemas.openxmlformats.org/drawingml/2006/main" xmlns:r="http://schemas.openxmlformats.org/officeDocument/2006/relationships" xmlns:p="http://schemas.openxmlformats.org/presentationml/2006/main">
-  <p:cSld>
-    <p:spTree>
-      <p:nvGrpSpPr>
-        <p:cNvPr id="1" name=""/>
-        <p:cNvGrpSpPr/>
-        <p:nvPr/>
-      </p:nvGrpSpPr>
-      <p:grpSpPr>
-        <a:xfrm>
-          <a:off x="0" y="0"/>
-          <a:ext cx="0" cy="0"/>
-          <a:chOff x="0" y="0"/>
-          <a:chExt cx="0" cy="0"/>
-        </a:xfrm>
-      </p:grpSpPr>
-      <p:sp>
-        <p:nvSpPr>
-          <p:cNvPr id="2" name="Title 1">
-            <a:extLst>
-              <a:ext uri="{FF2B5EF4-FFF2-40B4-BE49-F238E27FC236}">
-                <a16:creationId xmlns:a16="http://schemas.microsoft.com/office/drawing/2014/main" id="{8EEBE812-C639-0DE1-6B7A-FC54478B5362}"/>
-              </a:ext>
-            </a:extLst>
-          </p:cNvPr>
-          <p:cNvSpPr>
-            <a:spLocks noGrp="1"/>
-          </p:cNvSpPr>
-          <p:nvPr>
-            <p:ph type="title"/>
-          </p:nvPr>
-        </p:nvSpPr>
-        <p:spPr/>
-        <p:txBody>
-          <a:bodyPr/>
-          <a:lstStyle/>
-          <a:p>
-            <a:endParaRPr lang="en-US"/>
-          </a:p>
-        </p:txBody>
-      </p:sp>
-      <p:sp>
-        <p:nvSpPr>
-          <p:cNvPr id="3" name="Content Placeholder 2">
-            <a:extLst>
-              <a:ext uri="{FF2B5EF4-FFF2-40B4-BE49-F238E27FC236}">
-                <a16:creationId xmlns:a16="http://schemas.microsoft.com/office/drawing/2014/main" id="{4DA9F494-C72A-7E1D-05A8-E6D6BD423D75}"/>
-              </a:ext>
-            </a:extLst>
-          </p:cNvPr>
-          <p:cNvSpPr>
-            <a:spLocks noGrp="1"/>
-          </p:cNvSpPr>
-          <p:nvPr>
-            <p:ph idx="1"/>
-          </p:nvPr>
-        </p:nvSpPr>
-        <p:spPr/>
-        <p:txBody>
-          <a:bodyPr/>
-          <a:lstStyle/>
-          <a:p>
-            <a:endParaRPr lang="en-US"/>
-          </a:p>
-        </p:txBody>
-      </p:sp>
-      <p:sp>
-        <p:nvSpPr>
-          <p:cNvPr id="4" name="Slide Number Placeholder 3">
-            <a:extLst>
-              <a:ext uri="{FF2B5EF4-FFF2-40B4-BE49-F238E27FC236}">
-                <a16:creationId xmlns:a16="http://schemas.microsoft.com/office/drawing/2014/main" id="{88569CC1-DBA1-2C82-22D1-2097554AFA3A}"/>
-              </a:ext>
-            </a:extLst>
-          </p:cNvPr>
-          <p:cNvSpPr>
-            <a:spLocks noGrp="1"/>
-          </p:cNvSpPr>
-          <p:nvPr>
-            <p:ph type="sldNum" sz="quarter" idx="12"/>
-          </p:nvPr>
-        </p:nvSpPr>
-        <p:spPr/>
-        <p:txBody>
-          <a:bodyPr/>
-          <a:lstStyle/>
-          <a:p>
-            <a:fld id="{77E0F69E-94E4-477D-9D2E-ABE325801752}" type="slidenum">
-              <a:rPr lang="it-IT" smtClean="0"/>
-              <a:t>9</a:t>
-            </a:fld>
-            <a:endParaRPr lang="it-IT"/>
-          </a:p>
-        </p:txBody>
-      </p:sp>
-    </p:spTree>
-    <p:extLst>
-      <p:ext uri="{BB962C8B-B14F-4D97-AF65-F5344CB8AC3E}">
-        <p14:creationId xmlns:p14="http://schemas.microsoft.com/office/powerpoint/2010/main" val="1602372300"/>
       </p:ext>
     </p:extLst>
   </p:cSld>

</xml_diff>